<commit_message>
Add evaluation and training scripts for harmonic current classification
- Implemented `evaluate.py` to assess the detection pipeline on a labeled dataset, generating evaluation metrics and saving results to JSON and a calibrator model.
- Created `generate_harmonics.py` to synthesize current-harmonic signatures for training a 1D-CNN classifier, defining three classes: clean, legit_industrial, and illegal_bypass.
- Developed `train_harmonics.py` to train a 1D-CNN model on the generated harmonic dataset, saving the model state and metadata.
- Added artifacts for evaluation reports, model calibration, and harmonic data.
- Introduced JSON files for evaluation reports and model metadata to facilitate future analysis and model deployment.
</commit_message>
<xml_diff>
--- a/pitch/Grid-Pulse-NTL.pptx
+++ b/pitch/Grid-Pulse-NTL.pptx
@@ -12,6 +12,8 @@
     <p:sldId id="260" r:id="rId11"/>
     <p:sldId id="261" r:id="rId12"/>
     <p:sldId id="262" r:id="rId13"/>
+    <p:sldId id="263" r:id="rId14"/>
+    <p:sldId id="264" r:id="rId15"/>
   </p:sldIdLst>
   <p:sldSz cx="12191695" cy="6858000" type="screen4x3"/>
   <p:notesSz cx="6858000" cy="9144000"/>
@@ -10201,6 +10203,1043 @@
 </file>
 
 <file path=ppt/slides/slide7.xml><?xml version="1.0" encoding="utf-8"?>
+<p:sld xmlns:a="http://schemas.openxmlformats.org/drawingml/2006/main" xmlns:p="http://schemas.openxmlformats.org/presentationml/2006/main" xmlns:r="http://schemas.openxmlformats.org/officeDocument/2006/relationships">
+  <p:cSld>
+    <p:spTree>
+      <p:nvGrpSpPr>
+        <p:cNvPr id="1" name=""/>
+        <p:cNvGrpSpPr/>
+        <p:nvPr/>
+      </p:nvGrpSpPr>
+      <p:grpSpPr/>
+      <p:sp>
+        <p:nvSpPr>
+          <p:cNvPr id="2" name="Rectangle 1"/>
+          <p:cNvSpPr/>
+          <p:nvPr/>
+        </p:nvSpPr>
+        <p:spPr>
+          <a:xfrm>
+            <a:off x="0" y="0"/>
+            <a:ext cx="12191695" cy="6858000"/>
+          </a:xfrm>
+          <a:prstGeom prst="rect">
+            <a:avLst/>
+          </a:prstGeom>
+          <a:solidFill>
+            <a:srgbClr val="0A0E0F"/>
+          </a:solidFill>
+          <a:ln>
+            <a:noFill/>
+          </a:ln>
+          <a:effectLst/>
+        </p:spPr>
+        <p:style>
+          <a:lnRef idx="1">
+            <a:schemeClr val="accent1"/>
+          </a:lnRef>
+          <a:fillRef idx="3">
+            <a:schemeClr val="accent1"/>
+          </a:fillRef>
+          <a:effectRef idx="2">
+            <a:schemeClr val="accent1"/>
+          </a:effectRef>
+          <a:fontRef idx="minor">
+            <a:schemeClr val="lt1"/>
+          </a:fontRef>
+        </p:style>
+        <p:txBody>
+          <a:bodyPr rtlCol="0" anchor="ctr"/>
+          <a:lstStyle/>
+          <a:p>
+            <a:pPr algn="ctr"/>
+          </a:p>
+        </p:txBody>
+      </p:sp>
+      <p:sp>
+        <p:nvSpPr>
+          <p:cNvPr id="3" name="TextBox 2"/>
+          <p:cNvSpPr txBox="1"/>
+          <p:nvPr/>
+        </p:nvSpPr>
+        <p:spPr>
+          <a:xfrm>
+            <a:off x="640080" y="548640"/>
+            <a:ext cx="7315200" cy="365760"/>
+          </a:xfrm>
+          <a:prstGeom prst="rect">
+            <a:avLst/>
+          </a:prstGeom>
+          <a:noFill/>
+        </p:spPr>
+        <p:txBody>
+          <a:bodyPr wrap="square" anchor="t" lIns="0" rIns="0" tIns="0" bIns="0">
+            <a:spAutoFit/>
+          </a:bodyPr>
+          <a:lstStyle/>
+          <a:p>
+            <a:pPr algn="l">
+              <a:lnSpc>
+                <a:spcPct val="112000"/>
+              </a:lnSpc>
+              <a:spcBef>
+                <a:spcPts val="0"/>
+              </a:spcBef>
+              <a:spcAft>
+                <a:spcPts val="400"/>
+              </a:spcAft>
+            </a:pPr>
+            <a:r>
+              <a:rPr sz="1300" b="0" spc="100">
+                <a:solidFill>
+                  <a:srgbClr val="1C6A74"/>
+                </a:solidFill>
+                <a:latin typeface="Consolas"/>
+              </a:rPr>
+              <a:t>06   </a:t>
+            </a:r>
+            <a:r>
+              <a:rPr sz="1250" b="0" spc="260">
+                <a:solidFill>
+                  <a:srgbClr val="34C8E0"/>
+                </a:solidFill>
+                <a:latin typeface="Consolas"/>
+              </a:rPr>
+              <a:t>DEPLOYMENT · KAFR EL-SHEIKH</a:t>
+            </a:r>
+          </a:p>
+        </p:txBody>
+      </p:sp>
+      <p:sp>
+        <p:nvSpPr>
+          <p:cNvPr id="4" name="TextBox 3"/>
+          <p:cNvSpPr txBox="1"/>
+          <p:nvPr/>
+        </p:nvSpPr>
+        <p:spPr>
+          <a:xfrm>
+            <a:off x="640080" y="960120"/>
+            <a:ext cx="10881360" cy="914400"/>
+          </a:xfrm>
+          <a:prstGeom prst="rect">
+            <a:avLst/>
+          </a:prstGeom>
+          <a:noFill/>
+        </p:spPr>
+        <p:txBody>
+          <a:bodyPr wrap="square" anchor="t" lIns="0" rIns="0" tIns="0" bIns="0">
+            <a:spAutoFit/>
+          </a:bodyPr>
+          <a:lstStyle/>
+          <a:p>
+            <a:pPr algn="l">
+              <a:lnSpc>
+                <a:spcPct val="112000"/>
+              </a:lnSpc>
+              <a:spcBef>
+                <a:spcPts val="0"/>
+              </a:spcBef>
+              <a:spcAft>
+                <a:spcPts val="400"/>
+              </a:spcAft>
+            </a:pPr>
+            <a:r>
+              <a:rPr sz="3400" b="1">
+                <a:solidFill>
+                  <a:srgbClr val="E8EEF0"/>
+                </a:solidFill>
+                <a:latin typeface="Segoe UI Semibold"/>
+              </a:rPr>
+              <a:t>Onto the real iron box</a:t>
+            </a:r>
+          </a:p>
+        </p:txBody>
+      </p:sp>
+      <p:sp>
+        <p:nvSpPr>
+          <p:cNvPr id="5" name="TextBox 4"/>
+          <p:cNvSpPr txBox="1"/>
+          <p:nvPr/>
+        </p:nvSpPr>
+        <p:spPr>
+          <a:xfrm>
+            <a:off x="640080" y="1783080"/>
+            <a:ext cx="10881360" cy="640080"/>
+          </a:xfrm>
+          <a:prstGeom prst="rect">
+            <a:avLst/>
+          </a:prstGeom>
+          <a:noFill/>
+        </p:spPr>
+        <p:txBody>
+          <a:bodyPr wrap="square" anchor="t" lIns="0" rIns="0" tIns="0" bIns="0">
+            <a:spAutoFit/>
+          </a:bodyPr>
+          <a:lstStyle/>
+          <a:p>
+            <a:pPr algn="l">
+              <a:lnSpc>
+                <a:spcPct val="130000"/>
+              </a:lnSpc>
+              <a:spcBef>
+                <a:spcPts val="0"/>
+              </a:spcBef>
+              <a:spcAft>
+                <a:spcPts val="400"/>
+              </a:spcAft>
+            </a:pPr>
+            <a:r>
+              <a:rPr sz="1500" b="0">
+                <a:solidFill>
+                  <a:srgbClr val="8A9BA1"/>
+                </a:solidFill>
+                <a:latin typeface="Segoe UI"/>
+              </a:rPr>
+              <a:t>The field target is a sealed distribution kiosk (RMU). We retrofit it non-invasively on the low-voltage side — no outage, nothing bolted to the 11 kV.</a:t>
+            </a:r>
+          </a:p>
+        </p:txBody>
+      </p:sp>
+      <p:pic>
+        <p:nvPicPr>
+          <p:cNvPr id="6" name="Picture 5" descr="kiosk.jpg"/>
+          <p:cNvPicPr>
+            <a:picLocks noChangeAspect="1"/>
+          </p:cNvPicPr>
+          <p:nvPr/>
+        </p:nvPicPr>
+        <p:blipFill>
+          <a:blip r:embed="rId2"/>
+          <a:stretch>
+            <a:fillRect/>
+          </a:stretch>
+        </p:blipFill>
+        <p:spPr>
+          <a:xfrm>
+            <a:off x="822960" y="2743200"/>
+            <a:ext cx="3474720" cy="3026369"/>
+          </a:xfrm>
+          <a:prstGeom prst="rect">
+            <a:avLst/>
+          </a:prstGeom>
+          <a:ln w="15875">
+            <a:solidFill>
+              <a:srgbClr val="2A3A41"/>
+            </a:solidFill>
+          </a:ln>
+          <a:effectLst/>
+        </p:spPr>
+      </p:pic>
+      <p:sp>
+        <p:nvSpPr>
+          <p:cNvPr id="7" name="TextBox 6"/>
+          <p:cNvSpPr txBox="1"/>
+          <p:nvPr/>
+        </p:nvSpPr>
+        <p:spPr>
+          <a:xfrm>
+            <a:off x="822960" y="5806440"/>
+            <a:ext cx="3474720" cy="274320"/>
+          </a:xfrm>
+          <a:prstGeom prst="rect">
+            <a:avLst/>
+          </a:prstGeom>
+          <a:noFill/>
+        </p:spPr>
+        <p:txBody>
+          <a:bodyPr wrap="square" anchor="t" lIns="0" rIns="0" tIns="0" bIns="0">
+            <a:spAutoFit/>
+          </a:bodyPr>
+          <a:lstStyle/>
+          <a:p>
+            <a:pPr algn="l">
+              <a:lnSpc>
+                <a:spcPct val="112000"/>
+              </a:lnSpc>
+              <a:spcBef>
+                <a:spcPts val="0"/>
+              </a:spcBef>
+              <a:spcAft>
+                <a:spcPts val="400"/>
+              </a:spcAft>
+            </a:pPr>
+            <a:r>
+              <a:rPr sz="1000" b="0">
+                <a:solidFill>
+                  <a:srgbClr val="5F7178"/>
+                </a:solidFill>
+                <a:latin typeface="Consolas"/>
+              </a:rPr>
+              <a:t>Distribution kiosk (RMU) · Kafr El-Sheikh</a:t>
+            </a:r>
+          </a:p>
+        </p:txBody>
+      </p:sp>
+      <p:sp>
+        <p:nvSpPr>
+          <p:cNvPr id="8" name="TextBox 7"/>
+          <p:cNvSpPr txBox="1"/>
+          <p:nvPr/>
+        </p:nvSpPr>
+        <p:spPr>
+          <a:xfrm>
+            <a:off x="4846320" y="2880360"/>
+            <a:ext cx="6766560" cy="731520"/>
+          </a:xfrm>
+          <a:prstGeom prst="rect">
+            <a:avLst/>
+          </a:prstGeom>
+          <a:noFill/>
+        </p:spPr>
+        <p:txBody>
+          <a:bodyPr wrap="square" anchor="t" lIns="0" rIns="0" tIns="0" bIns="0">
+            <a:spAutoFit/>
+          </a:bodyPr>
+          <a:lstStyle/>
+          <a:p>
+            <a:pPr algn="l">
+              <a:lnSpc>
+                <a:spcPct val="112000"/>
+              </a:lnSpc>
+              <a:spcBef>
+                <a:spcPts val="0"/>
+              </a:spcBef>
+              <a:spcAft>
+                <a:spcPts val="400"/>
+              </a:spcAft>
+            </a:pPr>
+            <a:r>
+              <a:rPr sz="1400" b="1">
+                <a:solidFill>
+                  <a:srgbClr val="3DDC84"/>
+                </a:solidFill>
+                <a:latin typeface="Consolas"/>
+              </a:rPr>
+              <a:t>✓  </a:t>
+            </a:r>
+            <a:r>
+              <a:rPr sz="1600" b="1">
+                <a:solidFill>
+                  <a:srgbClr val="E8EEF0"/>
+                </a:solidFill>
+                <a:latin typeface="Segoe UI"/>
+              </a:rPr>
+              <a:t>Wrap 3 Rogowski coils</a:t>
+            </a:r>
+          </a:p>
+          <a:p>
+            <a:pPr algn="l">
+              <a:lnSpc>
+                <a:spcPct val="112000"/>
+              </a:lnSpc>
+              <a:spcBef>
+                <a:spcPts val="100"/>
+              </a:spcBef>
+              <a:spcAft>
+                <a:spcPts val="400"/>
+              </a:spcAft>
+            </a:pPr>
+            <a:r>
+              <a:rPr sz="1300" b="0">
+                <a:solidFill>
+                  <a:srgbClr val="8A9BA1"/>
+                </a:solidFill>
+                <a:latin typeface="Segoe UI"/>
+              </a:rPr>
+              <a:t>      around the LV busbars — one per phase</a:t>
+            </a:r>
+          </a:p>
+        </p:txBody>
+      </p:sp>
+      <p:sp>
+        <p:nvSpPr>
+          <p:cNvPr id="9" name="TextBox 8"/>
+          <p:cNvSpPr txBox="1"/>
+          <p:nvPr/>
+        </p:nvSpPr>
+        <p:spPr>
+          <a:xfrm>
+            <a:off x="4846320" y="3666744"/>
+            <a:ext cx="6766560" cy="731520"/>
+          </a:xfrm>
+          <a:prstGeom prst="rect">
+            <a:avLst/>
+          </a:prstGeom>
+          <a:noFill/>
+        </p:spPr>
+        <p:txBody>
+          <a:bodyPr wrap="square" anchor="t" lIns="0" rIns="0" tIns="0" bIns="0">
+            <a:spAutoFit/>
+          </a:bodyPr>
+          <a:lstStyle/>
+          <a:p>
+            <a:pPr algn="l">
+              <a:lnSpc>
+                <a:spcPct val="112000"/>
+              </a:lnSpc>
+              <a:spcBef>
+                <a:spcPts val="0"/>
+              </a:spcBef>
+              <a:spcAft>
+                <a:spcPts val="400"/>
+              </a:spcAft>
+            </a:pPr>
+            <a:r>
+              <a:rPr sz="1400" b="1">
+                <a:solidFill>
+                  <a:srgbClr val="3DDC84"/>
+                </a:solidFill>
+                <a:latin typeface="Consolas"/>
+              </a:rPr>
+              <a:t>✓  </a:t>
+            </a:r>
+            <a:r>
+              <a:rPr sz="1600" b="1">
+                <a:solidFill>
+                  <a:srgbClr val="E8EEF0"/>
+                </a:solidFill>
+                <a:latin typeface="Segoe UI"/>
+              </a:rPr>
+              <a:t>IP65 edge node</a:t>
+            </a:r>
+          </a:p>
+          <a:p>
+            <a:pPr algn="l">
+              <a:lnSpc>
+                <a:spcPct val="112000"/>
+              </a:lnSpc>
+              <a:spcBef>
+                <a:spcPts val="100"/>
+              </a:spcBef>
+              <a:spcAft>
+                <a:spcPts val="400"/>
+              </a:spcAft>
+            </a:pPr>
+            <a:r>
+              <a:rPr sz="1300" b="0">
+                <a:solidFill>
+                  <a:srgbClr val="8A9BA1"/>
+                </a:solidFill>
+                <a:latin typeface="Segoe UI"/>
+              </a:rPr>
+              <a:t>      custom PCB inside the panel; antenna routed outside the metal shell</a:t>
+            </a:r>
+          </a:p>
+        </p:txBody>
+      </p:sp>
+      <p:sp>
+        <p:nvSpPr>
+          <p:cNvPr id="10" name="TextBox 9"/>
+          <p:cNvSpPr txBox="1"/>
+          <p:nvPr/>
+        </p:nvSpPr>
+        <p:spPr>
+          <a:xfrm>
+            <a:off x="4846320" y="4453128"/>
+            <a:ext cx="6766560" cy="731520"/>
+          </a:xfrm>
+          <a:prstGeom prst="rect">
+            <a:avLst/>
+          </a:prstGeom>
+          <a:noFill/>
+        </p:spPr>
+        <p:txBody>
+          <a:bodyPr wrap="square" anchor="t" lIns="0" rIns="0" tIns="0" bIns="0">
+            <a:spAutoFit/>
+          </a:bodyPr>
+          <a:lstStyle/>
+          <a:p>
+            <a:pPr algn="l">
+              <a:lnSpc>
+                <a:spcPct val="112000"/>
+              </a:lnSpc>
+              <a:spcBef>
+                <a:spcPts val="0"/>
+              </a:spcBef>
+              <a:spcAft>
+                <a:spcPts val="400"/>
+              </a:spcAft>
+            </a:pPr>
+            <a:r>
+              <a:rPr sz="1400" b="1">
+                <a:solidFill>
+                  <a:srgbClr val="3DDC84"/>
+                </a:solidFill>
+                <a:latin typeface="Consolas"/>
+              </a:rPr>
+              <a:t>✓  </a:t>
+            </a:r>
+            <a:r>
+              <a:rPr sz="1600" b="1">
+                <a:solidFill>
+                  <a:srgbClr val="E8EEF0"/>
+                </a:solidFill>
+                <a:latin typeface="Segoe UI"/>
+              </a:rPr>
+              <a:t>MV chamber never touched</a:t>
+            </a:r>
+          </a:p>
+          <a:p>
+            <a:pPr algn="l">
+              <a:lnSpc>
+                <a:spcPct val="112000"/>
+              </a:lnSpc>
+              <a:spcBef>
+                <a:spcPts val="100"/>
+              </a:spcBef>
+              <a:spcAft>
+                <a:spcPts val="400"/>
+              </a:spcAft>
+            </a:pPr>
+            <a:r>
+              <a:rPr sz="1300" b="0">
+                <a:solidFill>
+                  <a:srgbClr val="8A9BA1"/>
+                </a:solidFill>
+                <a:latin typeface="Segoe UI"/>
+              </a:rPr>
+              <a:t>      no galvanic contact, no feeder disconnected</a:t>
+            </a:r>
+          </a:p>
+        </p:txBody>
+      </p:sp>
+      <p:sp>
+        <p:nvSpPr>
+          <p:cNvPr id="11" name="TextBox 10"/>
+          <p:cNvSpPr txBox="1"/>
+          <p:nvPr/>
+        </p:nvSpPr>
+        <p:spPr>
+          <a:xfrm>
+            <a:off x="4846320" y="5239512"/>
+            <a:ext cx="6766560" cy="731520"/>
+          </a:xfrm>
+          <a:prstGeom prst="rect">
+            <a:avLst/>
+          </a:prstGeom>
+          <a:noFill/>
+        </p:spPr>
+        <p:txBody>
+          <a:bodyPr wrap="square" anchor="t" lIns="0" rIns="0" tIns="0" bIns="0">
+            <a:spAutoFit/>
+          </a:bodyPr>
+          <a:lstStyle/>
+          <a:p>
+            <a:pPr algn="l">
+              <a:lnSpc>
+                <a:spcPct val="112000"/>
+              </a:lnSpc>
+              <a:spcBef>
+                <a:spcPts val="0"/>
+              </a:spcBef>
+              <a:spcAft>
+                <a:spcPts val="400"/>
+              </a:spcAft>
+            </a:pPr>
+            <a:r>
+              <a:rPr sz="1400" b="1">
+                <a:solidFill>
+                  <a:srgbClr val="3DDC84"/>
+                </a:solidFill>
+                <a:latin typeface="Consolas"/>
+              </a:rPr>
+              <a:t>✓  </a:t>
+            </a:r>
+            <a:r>
+              <a:rPr sz="1600" b="1">
+                <a:solidFill>
+                  <a:srgbClr val="E8EEF0"/>
+                </a:solidFill>
+                <a:latin typeface="Segoe UI"/>
+              </a:rPr>
+              <a:t>~30 min &amp; reversible</a:t>
+            </a:r>
+          </a:p>
+          <a:p>
+            <a:pPr algn="l">
+              <a:lnSpc>
+                <a:spcPct val="112000"/>
+              </a:lnSpc>
+              <a:spcBef>
+                <a:spcPts val="100"/>
+              </a:spcBef>
+              <a:spcAft>
+                <a:spcPts val="400"/>
+              </a:spcAft>
+            </a:pPr>
+            <a:r>
+              <a:rPr sz="1300" b="0">
+                <a:solidFill>
+                  <a:srgbClr val="8A9BA1"/>
+                </a:solidFill>
+                <a:latin typeface="Segoe UI"/>
+              </a:rPr>
+              <a:t>      zero service interruption — unclip and it's as it was</a:t>
+            </a:r>
+          </a:p>
+        </p:txBody>
+      </p:sp>
+    </p:spTree>
+  </p:cSld>
+  <p:clrMapOvr>
+    <a:masterClrMapping/>
+  </p:clrMapOvr>
+</p:sld>
+</file>
+
+<file path=ppt/slides/slide8.xml><?xml version="1.0" encoding="utf-8"?>
+<p:sld xmlns:a="http://schemas.openxmlformats.org/drawingml/2006/main" xmlns:p="http://schemas.openxmlformats.org/presentationml/2006/main" xmlns:r="http://schemas.openxmlformats.org/officeDocument/2006/relationships">
+  <p:cSld>
+    <p:spTree>
+      <p:nvGrpSpPr>
+        <p:cNvPr id="1" name=""/>
+        <p:cNvGrpSpPr/>
+        <p:nvPr/>
+      </p:nvGrpSpPr>
+      <p:grpSpPr/>
+      <p:sp>
+        <p:nvSpPr>
+          <p:cNvPr id="2" name="Rectangle 1"/>
+          <p:cNvSpPr/>
+          <p:nvPr/>
+        </p:nvSpPr>
+        <p:spPr>
+          <a:xfrm>
+            <a:off x="0" y="0"/>
+            <a:ext cx="12191695" cy="6858000"/>
+          </a:xfrm>
+          <a:prstGeom prst="rect">
+            <a:avLst/>
+          </a:prstGeom>
+          <a:solidFill>
+            <a:srgbClr val="0A0E0F"/>
+          </a:solidFill>
+          <a:ln>
+            <a:noFill/>
+          </a:ln>
+          <a:effectLst/>
+        </p:spPr>
+        <p:style>
+          <a:lnRef idx="1">
+            <a:schemeClr val="accent1"/>
+          </a:lnRef>
+          <a:fillRef idx="3">
+            <a:schemeClr val="accent1"/>
+          </a:fillRef>
+          <a:effectRef idx="2">
+            <a:schemeClr val="accent1"/>
+          </a:effectRef>
+          <a:fontRef idx="minor">
+            <a:schemeClr val="lt1"/>
+          </a:fontRef>
+        </p:style>
+        <p:txBody>
+          <a:bodyPr rtlCol="0" anchor="ctr"/>
+          <a:lstStyle/>
+          <a:p>
+            <a:pPr algn="ctr"/>
+          </a:p>
+        </p:txBody>
+      </p:sp>
+      <p:sp>
+        <p:nvSpPr>
+          <p:cNvPr id="3" name="TextBox 2"/>
+          <p:cNvSpPr txBox="1"/>
+          <p:nvPr/>
+        </p:nvSpPr>
+        <p:spPr>
+          <a:xfrm>
+            <a:off x="640080" y="548640"/>
+            <a:ext cx="7315200" cy="365760"/>
+          </a:xfrm>
+          <a:prstGeom prst="rect">
+            <a:avLst/>
+          </a:prstGeom>
+          <a:noFill/>
+        </p:spPr>
+        <p:txBody>
+          <a:bodyPr wrap="square" anchor="t" lIns="0" rIns="0" tIns="0" bIns="0">
+            <a:spAutoFit/>
+          </a:bodyPr>
+          <a:lstStyle/>
+          <a:p>
+            <a:pPr algn="l">
+              <a:lnSpc>
+                <a:spcPct val="112000"/>
+              </a:lnSpc>
+              <a:spcBef>
+                <a:spcPts val="0"/>
+              </a:spcBef>
+              <a:spcAft>
+                <a:spcPts val="400"/>
+              </a:spcAft>
+            </a:pPr>
+            <a:r>
+              <a:rPr sz="1300" b="0" spc="100">
+                <a:solidFill>
+                  <a:srgbClr val="1C6A74"/>
+                </a:solidFill>
+                <a:latin typeface="Consolas"/>
+              </a:rPr>
+              <a:t>07   </a:t>
+            </a:r>
+            <a:r>
+              <a:rPr sz="1250" b="0" spc="260">
+                <a:solidFill>
+                  <a:srgbClr val="34C8E0"/>
+                </a:solidFill>
+                <a:latin typeface="Consolas"/>
+              </a:rPr>
+              <a:t>THE PRODUCT · LIVE</a:t>
+            </a:r>
+          </a:p>
+        </p:txBody>
+      </p:sp>
+      <p:sp>
+        <p:nvSpPr>
+          <p:cNvPr id="4" name="TextBox 3"/>
+          <p:cNvSpPr txBox="1"/>
+          <p:nvPr/>
+        </p:nvSpPr>
+        <p:spPr>
+          <a:xfrm>
+            <a:off x="640080" y="960120"/>
+            <a:ext cx="10881360" cy="731520"/>
+          </a:xfrm>
+          <a:prstGeom prst="rect">
+            <a:avLst/>
+          </a:prstGeom>
+          <a:noFill/>
+        </p:spPr>
+        <p:txBody>
+          <a:bodyPr wrap="square" anchor="t" lIns="0" rIns="0" tIns="0" bIns="0">
+            <a:spAutoFit/>
+          </a:bodyPr>
+          <a:lstStyle/>
+          <a:p>
+            <a:pPr algn="l">
+              <a:lnSpc>
+                <a:spcPct val="112000"/>
+              </a:lnSpc>
+              <a:spcBef>
+                <a:spcPts val="0"/>
+              </a:spcBef>
+              <a:spcAft>
+                <a:spcPts val="400"/>
+              </a:spcAft>
+            </a:pPr>
+            <a:r>
+              <a:rPr sz="3400" b="1">
+                <a:solidFill>
+                  <a:srgbClr val="E8EEF0"/>
+                </a:solidFill>
+                <a:latin typeface="Segoe UI Semibold"/>
+              </a:rPr>
+              <a:t>Running, not rendered</a:t>
+            </a:r>
+          </a:p>
+        </p:txBody>
+      </p:sp>
+      <p:pic>
+        <p:nvPicPr>
+          <p:cNvPr id="5" name="Picture 4" descr="dashboard.jpg"/>
+          <p:cNvPicPr>
+            <a:picLocks noChangeAspect="1"/>
+          </p:cNvPicPr>
+          <p:nvPr/>
+        </p:nvPicPr>
+        <p:blipFill>
+          <a:blip r:embed="rId2"/>
+          <a:stretch>
+            <a:fillRect/>
+          </a:stretch>
+        </p:blipFill>
+        <p:spPr>
+          <a:xfrm>
+            <a:off x="640080" y="1783080"/>
+            <a:ext cx="4846320" cy="4710017"/>
+          </a:xfrm>
+          <a:prstGeom prst="rect">
+            <a:avLst/>
+          </a:prstGeom>
+          <a:ln w="15875">
+            <a:solidFill>
+              <a:srgbClr val="2A3A41"/>
+            </a:solidFill>
+          </a:ln>
+          <a:effectLst/>
+        </p:spPr>
+      </p:pic>
+      <p:sp>
+        <p:nvSpPr>
+          <p:cNvPr id="6" name="TextBox 5"/>
+          <p:cNvSpPr txBox="1"/>
+          <p:nvPr/>
+        </p:nvSpPr>
+        <p:spPr>
+          <a:xfrm>
+            <a:off x="5943600" y="2286000"/>
+            <a:ext cx="5577840" cy="822960"/>
+          </a:xfrm>
+          <a:prstGeom prst="rect">
+            <a:avLst/>
+          </a:prstGeom>
+          <a:noFill/>
+        </p:spPr>
+        <p:txBody>
+          <a:bodyPr wrap="square" anchor="t" lIns="0" rIns="0" tIns="0" bIns="0">
+            <a:spAutoFit/>
+          </a:bodyPr>
+          <a:lstStyle/>
+          <a:p>
+            <a:pPr algn="l">
+              <a:lnSpc>
+                <a:spcPct val="112000"/>
+              </a:lnSpc>
+              <a:spcBef>
+                <a:spcPts val="0"/>
+              </a:spcBef>
+              <a:spcAft>
+                <a:spcPts val="400"/>
+              </a:spcAft>
+            </a:pPr>
+            <a:r>
+              <a:rPr sz="4600" b="1">
+                <a:solidFill>
+                  <a:srgbClr val="FF4D5E"/>
+                </a:solidFill>
+                <a:latin typeface="Consolas"/>
+              </a:rPr>
+              <a:t>94%</a:t>
+            </a:r>
+            <a:r>
+              <a:rPr sz="1400" b="0">
+                <a:solidFill>
+                  <a:srgbClr val="8A9BA1"/>
+                </a:solidFill>
+                <a:latin typeface="Segoe UI"/>
+              </a:rPr>
+              <a:t>  live theft verdict</a:t>
+            </a:r>
+          </a:p>
+        </p:txBody>
+      </p:sp>
+      <p:sp>
+        <p:nvSpPr>
+          <p:cNvPr id="7" name="TextBox 6"/>
+          <p:cNvSpPr txBox="1"/>
+          <p:nvPr/>
+        </p:nvSpPr>
+        <p:spPr>
+          <a:xfrm>
+            <a:off x="5943600" y="3383280"/>
+            <a:ext cx="5577840" cy="548640"/>
+          </a:xfrm>
+          <a:prstGeom prst="rect">
+            <a:avLst/>
+          </a:prstGeom>
+          <a:noFill/>
+        </p:spPr>
+        <p:txBody>
+          <a:bodyPr wrap="square" anchor="t" lIns="0" rIns="0" tIns="0" bIns="0">
+            <a:spAutoFit/>
+          </a:bodyPr>
+          <a:lstStyle/>
+          <a:p>
+            <a:pPr algn="l">
+              <a:lnSpc>
+                <a:spcPct val="112000"/>
+              </a:lnSpc>
+              <a:spcBef>
+                <a:spcPts val="0"/>
+              </a:spcBef>
+              <a:spcAft>
+                <a:spcPts val="400"/>
+              </a:spcAft>
+            </a:pPr>
+            <a:r>
+              <a:rPr sz="1400" b="0">
+                <a:solidFill>
+                  <a:srgbClr val="34C8E0"/>
+                </a:solidFill>
+                <a:latin typeface="Consolas"/>
+              </a:rPr>
+              <a:t>›  </a:t>
+            </a:r>
+            <a:r>
+              <a:rPr sz="1400" b="0">
+                <a:solidFill>
+                  <a:srgbClr val="C3D0D4"/>
+                </a:solidFill>
+                <a:latin typeface="Segoe UI"/>
+              </a:rPr>
+              <a:t>Reasons checklist — 5/5 independent signals fired</a:t>
+            </a:r>
+          </a:p>
+        </p:txBody>
+      </p:sp>
+      <p:sp>
+        <p:nvSpPr>
+          <p:cNvPr id="8" name="TextBox 7"/>
+          <p:cNvSpPr txBox="1"/>
+          <p:nvPr/>
+        </p:nvSpPr>
+        <p:spPr>
+          <a:xfrm>
+            <a:off x="5943600" y="3950208"/>
+            <a:ext cx="5577840" cy="548640"/>
+          </a:xfrm>
+          <a:prstGeom prst="rect">
+            <a:avLst/>
+          </a:prstGeom>
+          <a:noFill/>
+        </p:spPr>
+        <p:txBody>
+          <a:bodyPr wrap="square" anchor="t" lIns="0" rIns="0" tIns="0" bIns="0">
+            <a:spAutoFit/>
+          </a:bodyPr>
+          <a:lstStyle/>
+          <a:p>
+            <a:pPr algn="l">
+              <a:lnSpc>
+                <a:spcPct val="112000"/>
+              </a:lnSpc>
+              <a:spcBef>
+                <a:spcPts val="0"/>
+              </a:spcBef>
+              <a:spcAft>
+                <a:spcPts val="400"/>
+              </a:spcAft>
+            </a:pPr>
+            <a:r>
+              <a:rPr sz="1400" b="0">
+                <a:solidFill>
+                  <a:srgbClr val="34C8E0"/>
+                </a:solidFill>
+                <a:latin typeface="Consolas"/>
+              </a:rPr>
+              <a:t>›  </a:t>
+            </a:r>
+            <a:r>
+              <a:rPr sz="1400" b="0">
+                <a:solidFill>
+                  <a:srgbClr val="C3D0D4"/>
+                </a:solidFill>
+                <a:latin typeface="Segoe UI"/>
+              </a:rPr>
+              <a:t>Colour-coded fleet map — green / amber / red at a glance</a:t>
+            </a:r>
+          </a:p>
+        </p:txBody>
+      </p:sp>
+      <p:sp>
+        <p:nvSpPr>
+          <p:cNvPr id="9" name="TextBox 8"/>
+          <p:cNvSpPr txBox="1"/>
+          <p:nvPr/>
+        </p:nvSpPr>
+        <p:spPr>
+          <a:xfrm>
+            <a:off x="5943600" y="4517136"/>
+            <a:ext cx="5577840" cy="548640"/>
+          </a:xfrm>
+          <a:prstGeom prst="rect">
+            <a:avLst/>
+          </a:prstGeom>
+          <a:noFill/>
+        </p:spPr>
+        <p:txBody>
+          <a:bodyPr wrap="square" anchor="t" lIns="0" rIns="0" tIns="0" bIns="0">
+            <a:spAutoFit/>
+          </a:bodyPr>
+          <a:lstStyle/>
+          <a:p>
+            <a:pPr algn="l">
+              <a:lnSpc>
+                <a:spcPct val="112000"/>
+              </a:lnSpc>
+              <a:spcBef>
+                <a:spcPts val="0"/>
+              </a:spcBef>
+              <a:spcAft>
+                <a:spcPts val="400"/>
+              </a:spcAft>
+            </a:pPr>
+            <a:r>
+              <a:rPr sz="1400" b="0">
+                <a:solidFill>
+                  <a:srgbClr val="34C8E0"/>
+                </a:solidFill>
+                <a:latin typeface="Consolas"/>
+              </a:rPr>
+              <a:t>›  </a:t>
+            </a:r>
+            <a:r>
+              <a:rPr sz="1400" b="0">
+                <a:solidFill>
+                  <a:srgbClr val="C3D0D4"/>
+                </a:solidFill>
+                <a:latin typeface="Segoe UI"/>
+              </a:rPr>
+              <a:t>Measured-loss trend + one-tap dispatch to inspection</a:t>
+            </a:r>
+          </a:p>
+        </p:txBody>
+      </p:sp>
+      <p:sp>
+        <p:nvSpPr>
+          <p:cNvPr id="10" name="TextBox 9"/>
+          <p:cNvSpPr txBox="1"/>
+          <p:nvPr/>
+        </p:nvSpPr>
+        <p:spPr>
+          <a:xfrm>
+            <a:off x="5943600" y="5221224"/>
+            <a:ext cx="5577840" cy="548640"/>
+          </a:xfrm>
+          <a:prstGeom prst="rect">
+            <a:avLst/>
+          </a:prstGeom>
+          <a:noFill/>
+        </p:spPr>
+        <p:txBody>
+          <a:bodyPr wrap="square" anchor="t" lIns="0" rIns="0" tIns="0" bIns="0">
+            <a:spAutoFit/>
+          </a:bodyPr>
+          <a:lstStyle/>
+          <a:p>
+            <a:pPr algn="l">
+              <a:lnSpc>
+                <a:spcPct val="112000"/>
+              </a:lnSpc>
+              <a:spcBef>
+                <a:spcPts val="0"/>
+              </a:spcBef>
+              <a:spcAft>
+                <a:spcPts val="400"/>
+              </a:spcAft>
+            </a:pPr>
+            <a:r>
+              <a:rPr sz="1250" b="0">
+                <a:solidFill>
+                  <a:srgbClr val="5F7178"/>
+                </a:solidFill>
+                <a:latin typeface="Segoe UI"/>
+              </a:rPr>
+              <a:t>Every figure in this deck comes straight out of this running system.</a:t>
+            </a:r>
+          </a:p>
+        </p:txBody>
+      </p:sp>
+    </p:spTree>
+  </p:cSld>
+  <p:clrMapOvr>
+    <a:masterClrMapping/>
+  </p:clrMapOvr>
+</p:sld>
+</file>
+
+<file path=ppt/slides/slide9.xml><?xml version="1.0" encoding="utf-8"?>
 <p:sld xmlns:a="http://schemas.openxmlformats.org/drawingml/2006/main" xmlns:p="http://schemas.openxmlformats.org/presentationml/2006/main" xmlns:r="http://schemas.openxmlformats.org/officeDocument/2006/relationships">
   <p:cSld>
     <p:spTree>

</xml_diff>